<commit_message>
docs: use Qural Hub branding in exhibition and presentation materials
</commit_message>
<xml_diff>
--- a/docs/presentation/deck-work/candidate.pptx
+++ b/docs/presentation/deck-work/candidate.pptx
@@ -461,7 +461,7 @@
           <a:lstStyle xmlns:a="http://schemas.openxmlformats.org/drawingml/2006/main"/>
           <a:p xmlns:a="http://schemas.openxmlformats.org/drawingml/2006/main">
             <a:r>
-              <a:t>Alageum Service Hub объединяет оборудование и весь процесс сервисного обслуживания. Проект студенческой команды университета предлагается для обсуждения возможного пилота. В интерфейсе используются демонстрационные данные, сотрудничество и внедрение в компании пока не подтверждены.</a:t>
+              <a:t>Qural Hub объединяет оборудование и весь процесс сервисного обслуживания. Проект студенческой команды университета предлагается для обсуждения возможного пилота. В интерфейсе используются демонстрационные данные, сотрудничество и внедрение в компании пока не подтверждены.</a:t>
             </a:r>
           </a:p>
           <a:p xmlns:a="http://schemas.openxmlformats.org/drawingml/2006/main">
@@ -5354,7 +5354,7 @@
       </p:sp>
       <p:sp>
         <p:nvSpPr>
-          <p:cNvPr id="4" name="ALAGEUM&#10;SERVICE HUB">
+          <p:cNvPr id="4" name="QURAL&#10;HUB">
             <a:extLst xmlns:a="http://schemas.openxmlformats.org/drawingml/2006/main">
               <a:ext uri="{FF2B5EF4-FFF2-40B4-BE49-F238E27FC236}">
                 <a16:creationId xmlns:a16="http://schemas.microsoft.com/office/drawing/2014/main" id="{25EE3570-84C9-4203-AFD1-47243A149935}"/>
@@ -5505,7 +5505,7 @@
                 <a:ea typeface="Arial"/>
                 <a:cs typeface="Arial"/>
               </a:rPr>
-              <a:t>ALAGEUM</a:t>
+              <a:t>QURAL</a:t>
             </a:r>
           </a:p>
           <a:p xmlns:a="http://schemas.openxmlformats.org/drawingml/2006/main">
@@ -5528,7 +5528,7 @@
                 <a:ea typeface="Arial"/>
                 <a:cs typeface="Arial"/>
               </a:rPr>
-              <a:t>SERVICE HUB</a:t>
+              <a:t>HUB</a:t>
             </a:r>
           </a:p>
         </p:txBody>
@@ -16539,7 +16539,7 @@
                           <a:ea typeface="Arial"/>
                           <a:cs typeface="Arial"/>
                         </a:rPr>
-                        <a:t>Что даёт Alageum Service Hub</a:t>
+                        <a:t>Что даёт Qural Hub</a:t>
                       </a:r>
                     </a:p>
                   </a:txBody>

</xml_diff>